<commit_message>
reran permutation analysis with limited model set for reptiles; updated resutls and figures
</commit_message>
<xml_diff>
--- a/figures/fig4/fig4.pptx
+++ b/figures/fig4/fig4.pptx
@@ -258,7 +258,7 @@
       </p15:sldGuideLst>
     </p:ext>
     <p:ext uri="http://customooxmlschemas.google.com/">
-      <go:slidesCustomData xmlns:go="http://customooxmlschemas.google.com/" xmlns:ahyp="http://schemas.microsoft.com/office/drawing/2018/hyperlinkcolor" xmlns:p15="http://schemas.microsoft.com/office/powerpoint/2012/main" xmlns:p14="http://schemas.microsoft.com/office/powerpoint/2010/main" xmlns:com="http://schemas.openxmlformats.org/drawingml/2006/compatibility" xmlns:pvml="urn:schemas-microsoft-com:office:powerpoint" xmlns:v="urn:schemas-microsoft-com:vml" xmlns:o="urn:schemas-microsoft-com:office:office" xmlns:dgm="http://schemas.openxmlformats.org/drawingml/2006/diagram" xmlns:c="http://schemas.openxmlformats.org/drawingml/2006/chart" xmlns:mv="urn:schemas-microsoft-com:mac:vml" xmlns:mc="http://schemas.openxmlformats.org/markup-compatibility/2006" xmlns="" r:id="rId10" roundtripDataSignature="AMtx7mhiytGPk8UOxiAGs9KaAxakDbg4SQ=="/>
+      <go:slidesCustomData xmlns="" xmlns:mc="http://schemas.openxmlformats.org/markup-compatibility/2006" xmlns:mv="urn:schemas-microsoft-com:mac:vml" xmlns:c="http://schemas.openxmlformats.org/drawingml/2006/chart" xmlns:dgm="http://schemas.openxmlformats.org/drawingml/2006/diagram" xmlns:o="urn:schemas-microsoft-com:office:office" xmlns:v="urn:schemas-microsoft-com:vml" xmlns:pvml="urn:schemas-microsoft-com:office:powerpoint" xmlns:com="http://schemas.openxmlformats.org/drawingml/2006/compatibility" xmlns:p14="http://schemas.microsoft.com/office/powerpoint/2010/main" xmlns:p15="http://schemas.microsoft.com/office/powerpoint/2012/main" xmlns:ahyp="http://schemas.microsoft.com/office/drawing/2018/hyperlinkcolor" xmlns:go="http://customooxmlschemas.google.com/" r:id="rId10" roundtripDataSignature="AMtx7mhiytGPk8UOxiAGs9KaAxakDbg4SQ=="/>
     </p:ext>
   </p:extLst>
 </p:presentation>
@@ -11917,10 +11917,10 @@
       </p:graphicFrame>
       <p:pic>
         <p:nvPicPr>
-          <p:cNvPr id="3" name="Graphic 2">
+          <p:cNvPr id="14" name="Graphic 13">
             <a:extLst>
               <a:ext uri="{FF2B5EF4-FFF2-40B4-BE49-F238E27FC236}">
-                <a16:creationId xmlns:a16="http://schemas.microsoft.com/office/drawing/2014/main" id="{6C3B1818-E129-ED6E-3E61-D8C19D286680}"/>
+                <a16:creationId xmlns:a16="http://schemas.microsoft.com/office/drawing/2014/main" id="{9937D611-4580-8F92-F71F-B6A811E7D90F}"/>
               </a:ext>
             </a:extLst>
           </p:cNvPr>
@@ -11937,15 +11937,15 @@
               </a:ext>
             </a:extLst>
           </a:blip>
-          <a:srcRect l="2908" r="14216"/>
+          <a:srcRect l="3066" r="14193" b="711"/>
           <a:stretch>
             <a:fillRect/>
           </a:stretch>
         </p:blipFill>
         <p:spPr>
           <a:xfrm>
-            <a:off x="2514600" y="8520080"/>
-            <a:ext cx="30403800" cy="15878239"/>
+            <a:off x="1120876" y="8619527"/>
+            <a:ext cx="30263691" cy="15567828"/>
           </a:xfrm>
           <a:prstGeom prst="rect">
             <a:avLst/>
@@ -11992,10 +11992,10 @@
       </p:grpSpPr>
       <p:pic>
         <p:nvPicPr>
-          <p:cNvPr id="3" name="Picture 2">
+          <p:cNvPr id="46" name="Picture 45">
             <a:extLst>
               <a:ext uri="{FF2B5EF4-FFF2-40B4-BE49-F238E27FC236}">
-                <a16:creationId xmlns:a16="http://schemas.microsoft.com/office/drawing/2014/main" id="{FD573FA7-8B6E-5D01-4A09-55E20F7D9319}"/>
+                <a16:creationId xmlns:a16="http://schemas.microsoft.com/office/drawing/2014/main" id="{8D818C2F-76C0-8EC8-3A95-BA815E49FA3F}"/>
               </a:ext>
             </a:extLst>
           </p:cNvPr>
@@ -12006,15 +12006,15 @@
         </p:nvPicPr>
         <p:blipFill>
           <a:blip r:embed="rId3"/>
-          <a:srcRect l="18142" t="14516" r="27112" b="21935"/>
+          <a:srcRect l="18210" t="14514" r="27182" b="21937"/>
           <a:stretch>
             <a:fillRect/>
           </a:stretch>
         </p:blipFill>
         <p:spPr>
           <a:xfrm>
-            <a:off x="17285599" y="16697376"/>
-            <a:ext cx="4009834" cy="2316628"/>
+            <a:off x="17433830" y="16697404"/>
+            <a:ext cx="3999716" cy="2316628"/>
           </a:xfrm>
           <a:prstGeom prst="rect">
             <a:avLst/>
@@ -12106,7 +12106,7 @@
         </p:blipFill>
         <p:spPr>
           <a:xfrm>
-            <a:off x="17301761" y="13670274"/>
+            <a:off x="17444636" y="13670274"/>
             <a:ext cx="3993671" cy="2316628"/>
           </a:xfrm>
           <a:prstGeom prst="rect">
@@ -12632,7 +12632,7 @@
         </p:nvSpPr>
         <p:spPr>
           <a:xfrm>
-            <a:off x="17302202" y="15974209"/>
+            <a:off x="17445077" y="15974209"/>
             <a:ext cx="339726" cy="276999"/>
           </a:xfrm>
           <a:prstGeom prst="rect">
@@ -12668,7 +12668,7 @@
         </p:nvSpPr>
         <p:spPr>
           <a:xfrm>
-            <a:off x="17626117" y="15974208"/>
+            <a:off x="17768992" y="15974208"/>
             <a:ext cx="339726" cy="276999"/>
           </a:xfrm>
           <a:prstGeom prst="rect">
@@ -12704,7 +12704,7 @@
         </p:nvSpPr>
         <p:spPr>
           <a:xfrm>
-            <a:off x="17954794" y="15974208"/>
+            <a:off x="18097669" y="15974208"/>
             <a:ext cx="339726" cy="276999"/>
           </a:xfrm>
           <a:prstGeom prst="rect">
@@ -12740,7 +12740,7 @@
         </p:nvSpPr>
         <p:spPr>
           <a:xfrm>
-            <a:off x="18281949" y="15974207"/>
+            <a:off x="18424824" y="15974207"/>
             <a:ext cx="339726" cy="276999"/>
           </a:xfrm>
           <a:prstGeom prst="rect">
@@ -12776,7 +12776,7 @@
         </p:nvSpPr>
         <p:spPr>
           <a:xfrm>
-            <a:off x="18604342" y="15974207"/>
+            <a:off x="18747217" y="15974207"/>
             <a:ext cx="339726" cy="276999"/>
           </a:xfrm>
           <a:prstGeom prst="rect">
@@ -12812,7 +12812,7 @@
         </p:nvSpPr>
         <p:spPr>
           <a:xfrm>
-            <a:off x="18933878" y="15974206"/>
+            <a:off x="19076753" y="15974206"/>
             <a:ext cx="339726" cy="276999"/>
           </a:xfrm>
           <a:prstGeom prst="rect">
@@ -12848,7 +12848,7 @@
         </p:nvSpPr>
         <p:spPr>
           <a:xfrm>
-            <a:off x="19327813" y="15974206"/>
+            <a:off x="19470688" y="15974206"/>
             <a:ext cx="339726" cy="276999"/>
           </a:xfrm>
           <a:prstGeom prst="rect">
@@ -12884,7 +12884,7 @@
         </p:nvSpPr>
         <p:spPr>
           <a:xfrm>
-            <a:off x="19651728" y="15974205"/>
+            <a:off x="19794603" y="15974205"/>
             <a:ext cx="339726" cy="276999"/>
           </a:xfrm>
           <a:prstGeom prst="rect">
@@ -12920,7 +12920,7 @@
         </p:nvSpPr>
         <p:spPr>
           <a:xfrm>
-            <a:off x="19980405" y="15974205"/>
+            <a:off x="20123280" y="15974205"/>
             <a:ext cx="339726" cy="276999"/>
           </a:xfrm>
           <a:prstGeom prst="rect">
@@ -12956,7 +12956,7 @@
         </p:nvSpPr>
         <p:spPr>
           <a:xfrm>
-            <a:off x="20307560" y="15974204"/>
+            <a:off x="20450435" y="15974204"/>
             <a:ext cx="339726" cy="276999"/>
           </a:xfrm>
           <a:prstGeom prst="rect">
@@ -12992,7 +12992,7 @@
         </p:nvSpPr>
         <p:spPr>
           <a:xfrm>
-            <a:off x="20629953" y="15974204"/>
+            <a:off x="20772828" y="15974204"/>
             <a:ext cx="339726" cy="276999"/>
           </a:xfrm>
           <a:prstGeom prst="rect">
@@ -13028,7 +13028,7 @@
         </p:nvSpPr>
         <p:spPr>
           <a:xfrm>
-            <a:off x="20959489" y="15974203"/>
+            <a:off x="21102364" y="15974203"/>
             <a:ext cx="339726" cy="276999"/>
           </a:xfrm>
           <a:prstGeom prst="rect">
@@ -13424,7 +13424,7 @@
         </p:nvSpPr>
         <p:spPr>
           <a:xfrm>
-            <a:off x="17282424" y="19001341"/>
+            <a:off x="17505269" y="19004694"/>
             <a:ext cx="339726" cy="261610"/>
           </a:xfrm>
           <a:prstGeom prst="rect">
@@ -13441,7 +13441,7 @@
             <a:pPr algn="ctr"/>
             <a:r>
               <a:rPr lang="en-US" sz="1100" dirty="0"/>
-              <a:t>-8</a:t>
+              <a:t>-1</a:t>
             </a:r>
           </a:p>
         </p:txBody>
@@ -13460,8 +13460,8 @@
         </p:nvSpPr>
         <p:spPr>
           <a:xfrm>
-            <a:off x="17784871" y="19001341"/>
-            <a:ext cx="339726" cy="261610"/>
+            <a:off x="17849162" y="19001341"/>
+            <a:ext cx="461156" cy="261610"/>
           </a:xfrm>
           <a:prstGeom prst="rect">
             <a:avLst/>
@@ -13477,7 +13477,7 @@
             <a:pPr algn="ctr"/>
             <a:r>
               <a:rPr lang="en-US" sz="1100" dirty="0"/>
-              <a:t>-4</a:t>
+              <a:t>-0.5</a:t>
             </a:r>
           </a:p>
         </p:txBody>
@@ -13496,7 +13496,7 @@
         </p:nvSpPr>
         <p:spPr>
           <a:xfrm>
-            <a:off x="18287699" y="19001332"/>
+            <a:off x="18313893" y="19001332"/>
             <a:ext cx="339726" cy="261610"/>
           </a:xfrm>
           <a:prstGeom prst="rect">
@@ -13532,8 +13532,8 @@
         </p:nvSpPr>
         <p:spPr>
           <a:xfrm>
-            <a:off x="18540112" y="19001331"/>
-            <a:ext cx="339726" cy="261610"/>
+            <a:off x="18635361" y="19001331"/>
+            <a:ext cx="502448" cy="261610"/>
           </a:xfrm>
           <a:prstGeom prst="rect">
             <a:avLst/>
@@ -13549,43 +13549,7 @@
             <a:pPr algn="ctr"/>
             <a:r>
               <a:rPr lang="en-US" sz="1100" dirty="0"/>
-              <a:t>2</a:t>
-            </a:r>
-          </a:p>
-        </p:txBody>
-      </p:sp>
-      <p:sp>
-        <p:nvSpPr>
-          <p:cNvPr id="48" name="TextBox 47">
-            <a:extLst>
-              <a:ext uri="{FF2B5EF4-FFF2-40B4-BE49-F238E27FC236}">
-                <a16:creationId xmlns:a16="http://schemas.microsoft.com/office/drawing/2014/main" id="{29D5BAA2-8C3D-615F-33AC-6CC2DA2986DD}"/>
-              </a:ext>
-            </a:extLst>
-          </p:cNvPr>
-          <p:cNvSpPr txBox="1"/>
-          <p:nvPr/>
-        </p:nvSpPr>
-        <p:spPr>
-          <a:xfrm>
-            <a:off x="18792525" y="19001330"/>
-            <a:ext cx="339726" cy="261610"/>
-          </a:xfrm>
-          <a:prstGeom prst="rect">
-            <a:avLst/>
-          </a:prstGeom>
-          <a:noFill/>
-        </p:spPr>
-        <p:txBody>
-          <a:bodyPr wrap="square" rtlCol="0">
-            <a:spAutoFit/>
-          </a:bodyPr>
-          <a:lstStyle/>
-          <a:p>
-            <a:pPr algn="ctr"/>
-            <a:r>
-              <a:rPr lang="en-US" sz="1100" dirty="0"/>
-              <a:t>4</a:t>
+              <a:t>0.5</a:t>
             </a:r>
           </a:p>
         </p:txBody>
@@ -13604,7 +13568,7 @@
         </p:nvSpPr>
         <p:spPr>
           <a:xfrm>
-            <a:off x="19042559" y="19001330"/>
+            <a:off x="19121137" y="19001330"/>
             <a:ext cx="339726" cy="261610"/>
           </a:xfrm>
           <a:prstGeom prst="rect">
@@ -13621,979 +13585,7 @@
             <a:pPr algn="ctr"/>
             <a:r>
               <a:rPr lang="en-US" sz="1100" dirty="0"/>
-              <a:t>6</a:t>
-            </a:r>
-          </a:p>
-        </p:txBody>
-      </p:sp>
-      <p:sp>
-        <p:nvSpPr>
-          <p:cNvPr id="50" name="TextBox 49">
-            <a:extLst>
-              <a:ext uri="{FF2B5EF4-FFF2-40B4-BE49-F238E27FC236}">
-                <a16:creationId xmlns:a16="http://schemas.microsoft.com/office/drawing/2014/main" id="{3BCB0472-CC38-595E-4955-929E25714C5F}"/>
-              </a:ext>
-            </a:extLst>
-          </p:cNvPr>
-          <p:cNvSpPr txBox="1"/>
-          <p:nvPr/>
-        </p:nvSpPr>
-        <p:spPr>
-          <a:xfrm>
-            <a:off x="18037286" y="19001329"/>
-            <a:ext cx="339726" cy="261610"/>
-          </a:xfrm>
-          <a:prstGeom prst="rect">
-            <a:avLst/>
-          </a:prstGeom>
-          <a:noFill/>
-        </p:spPr>
-        <p:txBody>
-          <a:bodyPr wrap="square" rtlCol="0">
-            <a:spAutoFit/>
-          </a:bodyPr>
-          <a:lstStyle/>
-          <a:p>
-            <a:pPr algn="ctr"/>
-            <a:r>
-              <a:rPr lang="en-US" sz="1100" dirty="0"/>
-              <a:t>-2</a:t>
-            </a:r>
-          </a:p>
-        </p:txBody>
-      </p:sp>
-      <p:sp>
-        <p:nvSpPr>
-          <p:cNvPr id="51" name="TextBox 50">
-            <a:extLst>
-              <a:ext uri="{FF2B5EF4-FFF2-40B4-BE49-F238E27FC236}">
-                <a16:creationId xmlns:a16="http://schemas.microsoft.com/office/drawing/2014/main" id="{49BB7541-A03F-1189-759A-1AB0067CF741}"/>
-              </a:ext>
-            </a:extLst>
-          </p:cNvPr>
-          <p:cNvSpPr txBox="1"/>
-          <p:nvPr/>
-        </p:nvSpPr>
-        <p:spPr>
-          <a:xfrm>
-            <a:off x="17532847" y="19001329"/>
-            <a:ext cx="339726" cy="261610"/>
-          </a:xfrm>
-          <a:prstGeom prst="rect">
-            <a:avLst/>
-          </a:prstGeom>
-          <a:noFill/>
-        </p:spPr>
-        <p:txBody>
-          <a:bodyPr wrap="square" rtlCol="0">
-            <a:spAutoFit/>
-          </a:bodyPr>
-          <a:lstStyle/>
-          <a:p>
-            <a:pPr algn="ctr"/>
-            <a:r>
-              <a:rPr lang="en-US" sz="1100" dirty="0"/>
-              <a:t>-6</a:t>
-            </a:r>
-          </a:p>
-        </p:txBody>
-      </p:sp>
-      <p:sp>
-        <p:nvSpPr>
-          <p:cNvPr id="60" name="TextBox 59">
-            <a:extLst>
-              <a:ext uri="{FF2B5EF4-FFF2-40B4-BE49-F238E27FC236}">
-                <a16:creationId xmlns:a16="http://schemas.microsoft.com/office/drawing/2014/main" id="{82BADAB7-E49E-3F3D-F8E7-65241F819131}"/>
-              </a:ext>
-            </a:extLst>
-          </p:cNvPr>
-          <p:cNvSpPr txBox="1"/>
-          <p:nvPr/>
-        </p:nvSpPr>
-        <p:spPr>
-          <a:xfrm>
-            <a:off x="19336644" y="19001329"/>
-            <a:ext cx="339726" cy="261610"/>
-          </a:xfrm>
-          <a:prstGeom prst="rect">
-            <a:avLst/>
-          </a:prstGeom>
-          <a:noFill/>
-        </p:spPr>
-        <p:txBody>
-          <a:bodyPr wrap="square" rtlCol="0">
-            <a:spAutoFit/>
-          </a:bodyPr>
-          <a:lstStyle/>
-          <a:p>
-            <a:pPr algn="ctr"/>
-            <a:r>
-              <a:rPr lang="en-US" sz="1100" dirty="0"/>
-              <a:t>-8</a:t>
-            </a:r>
-          </a:p>
-        </p:txBody>
-      </p:sp>
-      <p:sp>
-        <p:nvSpPr>
-          <p:cNvPr id="61" name="TextBox 60">
-            <a:extLst>
-              <a:ext uri="{FF2B5EF4-FFF2-40B4-BE49-F238E27FC236}">
-                <a16:creationId xmlns:a16="http://schemas.microsoft.com/office/drawing/2014/main" id="{71FD222C-9F7C-B419-48B3-F2B9E92B4C25}"/>
-              </a:ext>
-            </a:extLst>
-          </p:cNvPr>
-          <p:cNvSpPr txBox="1"/>
-          <p:nvPr/>
-        </p:nvSpPr>
-        <p:spPr>
-          <a:xfrm>
-            <a:off x="19839091" y="19001329"/>
-            <a:ext cx="339726" cy="261610"/>
-          </a:xfrm>
-          <a:prstGeom prst="rect">
-            <a:avLst/>
-          </a:prstGeom>
-          <a:noFill/>
-        </p:spPr>
-        <p:txBody>
-          <a:bodyPr wrap="square" rtlCol="0">
-            <a:spAutoFit/>
-          </a:bodyPr>
-          <a:lstStyle/>
-          <a:p>
-            <a:pPr algn="ctr"/>
-            <a:r>
-              <a:rPr lang="en-US" sz="1100" dirty="0"/>
-              <a:t>-4</a:t>
-            </a:r>
-          </a:p>
-        </p:txBody>
-      </p:sp>
-      <p:sp>
-        <p:nvSpPr>
-          <p:cNvPr id="62" name="TextBox 61">
-            <a:extLst>
-              <a:ext uri="{FF2B5EF4-FFF2-40B4-BE49-F238E27FC236}">
-                <a16:creationId xmlns:a16="http://schemas.microsoft.com/office/drawing/2014/main" id="{B036FDA3-5F79-968E-1E69-F1B57C3C80C9}"/>
-              </a:ext>
-            </a:extLst>
-          </p:cNvPr>
-          <p:cNvSpPr txBox="1"/>
-          <p:nvPr/>
-        </p:nvSpPr>
-        <p:spPr>
-          <a:xfrm>
-            <a:off x="20341919" y="19001320"/>
-            <a:ext cx="339726" cy="261610"/>
-          </a:xfrm>
-          <a:prstGeom prst="rect">
-            <a:avLst/>
-          </a:prstGeom>
-          <a:noFill/>
-        </p:spPr>
-        <p:txBody>
-          <a:bodyPr wrap="square" rtlCol="0">
-            <a:spAutoFit/>
-          </a:bodyPr>
-          <a:lstStyle/>
-          <a:p>
-            <a:pPr algn="ctr"/>
-            <a:r>
-              <a:rPr lang="en-US" sz="1100" dirty="0"/>
-              <a:t>0</a:t>
-            </a:r>
-          </a:p>
-        </p:txBody>
-      </p:sp>
-      <p:sp>
-        <p:nvSpPr>
-          <p:cNvPr id="63" name="TextBox 62">
-            <a:extLst>
-              <a:ext uri="{FF2B5EF4-FFF2-40B4-BE49-F238E27FC236}">
-                <a16:creationId xmlns:a16="http://schemas.microsoft.com/office/drawing/2014/main" id="{CBEADC6F-2FD8-42C0-F4EC-7D2BB92035A4}"/>
-              </a:ext>
-            </a:extLst>
-          </p:cNvPr>
-          <p:cNvSpPr txBox="1"/>
-          <p:nvPr/>
-        </p:nvSpPr>
-        <p:spPr>
-          <a:xfrm>
-            <a:off x="20594332" y="19001319"/>
-            <a:ext cx="339726" cy="261610"/>
-          </a:xfrm>
-          <a:prstGeom prst="rect">
-            <a:avLst/>
-          </a:prstGeom>
-          <a:noFill/>
-        </p:spPr>
-        <p:txBody>
-          <a:bodyPr wrap="square" rtlCol="0">
-            <a:spAutoFit/>
-          </a:bodyPr>
-          <a:lstStyle/>
-          <a:p>
-            <a:pPr algn="ctr"/>
-            <a:r>
-              <a:rPr lang="en-US" sz="1100" dirty="0"/>
-              <a:t>2</a:t>
-            </a:r>
-          </a:p>
-        </p:txBody>
-      </p:sp>
-      <p:sp>
-        <p:nvSpPr>
-          <p:cNvPr id="64" name="TextBox 63">
-            <a:extLst>
-              <a:ext uri="{FF2B5EF4-FFF2-40B4-BE49-F238E27FC236}">
-                <a16:creationId xmlns:a16="http://schemas.microsoft.com/office/drawing/2014/main" id="{7ED26D36-D7FD-0AEF-679D-A18C191DA2DB}"/>
-              </a:ext>
-            </a:extLst>
-          </p:cNvPr>
-          <p:cNvSpPr txBox="1"/>
-          <p:nvPr/>
-        </p:nvSpPr>
-        <p:spPr>
-          <a:xfrm>
-            <a:off x="20846745" y="19001318"/>
-            <a:ext cx="339726" cy="261610"/>
-          </a:xfrm>
-          <a:prstGeom prst="rect">
-            <a:avLst/>
-          </a:prstGeom>
-          <a:noFill/>
-        </p:spPr>
-        <p:txBody>
-          <a:bodyPr wrap="square" rtlCol="0">
-            <a:spAutoFit/>
-          </a:bodyPr>
-          <a:lstStyle/>
-          <a:p>
-            <a:pPr algn="ctr"/>
-            <a:r>
-              <a:rPr lang="en-US" sz="1100" dirty="0"/>
-              <a:t>4</a:t>
-            </a:r>
-          </a:p>
-        </p:txBody>
-      </p:sp>
-      <p:sp>
-        <p:nvSpPr>
-          <p:cNvPr id="65" name="TextBox 64">
-            <a:extLst>
-              <a:ext uri="{FF2B5EF4-FFF2-40B4-BE49-F238E27FC236}">
-                <a16:creationId xmlns:a16="http://schemas.microsoft.com/office/drawing/2014/main" id="{E27E783E-F99B-E81F-1098-04B843DCC79E}"/>
-              </a:ext>
-            </a:extLst>
-          </p:cNvPr>
-          <p:cNvSpPr txBox="1"/>
-          <p:nvPr/>
-        </p:nvSpPr>
-        <p:spPr>
-          <a:xfrm>
-            <a:off x="21096779" y="19001318"/>
-            <a:ext cx="339726" cy="261610"/>
-          </a:xfrm>
-          <a:prstGeom prst="rect">
-            <a:avLst/>
-          </a:prstGeom>
-          <a:noFill/>
-        </p:spPr>
-        <p:txBody>
-          <a:bodyPr wrap="square" rtlCol="0">
-            <a:spAutoFit/>
-          </a:bodyPr>
-          <a:lstStyle/>
-          <a:p>
-            <a:pPr algn="ctr"/>
-            <a:r>
-              <a:rPr lang="en-US" sz="1100" dirty="0"/>
-              <a:t>6</a:t>
-            </a:r>
-          </a:p>
-        </p:txBody>
-      </p:sp>
-      <p:sp>
-        <p:nvSpPr>
-          <p:cNvPr id="66" name="TextBox 65">
-            <a:extLst>
-              <a:ext uri="{FF2B5EF4-FFF2-40B4-BE49-F238E27FC236}">
-                <a16:creationId xmlns:a16="http://schemas.microsoft.com/office/drawing/2014/main" id="{157F2156-EB90-DF26-B88D-6CE4A0C9F98F}"/>
-              </a:ext>
-            </a:extLst>
-          </p:cNvPr>
-          <p:cNvSpPr txBox="1"/>
-          <p:nvPr/>
-        </p:nvSpPr>
-        <p:spPr>
-          <a:xfrm>
-            <a:off x="20091506" y="19001317"/>
-            <a:ext cx="339726" cy="261610"/>
-          </a:xfrm>
-          <a:prstGeom prst="rect">
-            <a:avLst/>
-          </a:prstGeom>
-          <a:noFill/>
-        </p:spPr>
-        <p:txBody>
-          <a:bodyPr wrap="square" rtlCol="0">
-            <a:spAutoFit/>
-          </a:bodyPr>
-          <a:lstStyle/>
-          <a:p>
-            <a:pPr algn="ctr"/>
-            <a:r>
-              <a:rPr lang="en-US" sz="1100" dirty="0"/>
-              <a:t>-2</a:t>
-            </a:r>
-          </a:p>
-        </p:txBody>
-      </p:sp>
-      <p:sp>
-        <p:nvSpPr>
-          <p:cNvPr id="67" name="TextBox 66">
-            <a:extLst>
-              <a:ext uri="{FF2B5EF4-FFF2-40B4-BE49-F238E27FC236}">
-                <a16:creationId xmlns:a16="http://schemas.microsoft.com/office/drawing/2014/main" id="{B9E4426E-420E-B68E-E4E4-4AF5908012F6}"/>
-              </a:ext>
-            </a:extLst>
-          </p:cNvPr>
-          <p:cNvSpPr txBox="1"/>
-          <p:nvPr/>
-        </p:nvSpPr>
-        <p:spPr>
-          <a:xfrm>
-            <a:off x="19587067" y="19001317"/>
-            <a:ext cx="339726" cy="261610"/>
-          </a:xfrm>
-          <a:prstGeom prst="rect">
-            <a:avLst/>
-          </a:prstGeom>
-          <a:noFill/>
-        </p:spPr>
-        <p:txBody>
-          <a:bodyPr wrap="square" rtlCol="0">
-            <a:spAutoFit/>
-          </a:bodyPr>
-          <a:lstStyle/>
-          <a:p>
-            <a:pPr algn="ctr"/>
-            <a:r>
-              <a:rPr lang="en-US" sz="1100" dirty="0"/>
-              <a:t>-6</a:t>
-            </a:r>
-          </a:p>
-        </p:txBody>
-      </p:sp>
-      <p:sp>
-        <p:nvSpPr>
-          <p:cNvPr id="68" name="TextBox 67">
-            <a:extLst>
-              <a:ext uri="{FF2B5EF4-FFF2-40B4-BE49-F238E27FC236}">
-                <a16:creationId xmlns:a16="http://schemas.microsoft.com/office/drawing/2014/main" id="{8363BCE0-20EE-BB05-6BD2-FFB7AB12AA7F}"/>
-              </a:ext>
-            </a:extLst>
-          </p:cNvPr>
-          <p:cNvSpPr txBox="1"/>
-          <p:nvPr/>
-        </p:nvSpPr>
-        <p:spPr>
-          <a:xfrm>
-            <a:off x="15818874" y="16775700"/>
-            <a:ext cx="1524000" cy="215444"/>
-          </a:xfrm>
-          <a:prstGeom prst="rect">
-            <a:avLst/>
-          </a:prstGeom>
-          <a:noFill/>
-        </p:spPr>
-        <p:txBody>
-          <a:bodyPr wrap="square" rtlCol="0">
-            <a:spAutoFit/>
-          </a:bodyPr>
-          <a:lstStyle/>
-          <a:p>
-            <a:pPr algn="r"/>
-            <a:r>
-              <a:rPr lang="en-US" sz="800" dirty="0"/>
-              <a:t>DNA age</a:t>
-            </a:r>
-          </a:p>
-        </p:txBody>
-      </p:sp>
-      <p:sp>
-        <p:nvSpPr>
-          <p:cNvPr id="69" name="TextBox 68">
-            <a:extLst>
-              <a:ext uri="{FF2B5EF4-FFF2-40B4-BE49-F238E27FC236}">
-                <a16:creationId xmlns:a16="http://schemas.microsoft.com/office/drawing/2014/main" id="{B27E41CF-44FF-0D54-A73D-79E298C48173}"/>
-              </a:ext>
-            </a:extLst>
-          </p:cNvPr>
-          <p:cNvSpPr txBox="1"/>
-          <p:nvPr/>
-        </p:nvSpPr>
-        <p:spPr>
-          <a:xfrm>
-            <a:off x="15818874" y="17006532"/>
-            <a:ext cx="1524000" cy="215444"/>
-          </a:xfrm>
-          <a:prstGeom prst="rect">
-            <a:avLst/>
-          </a:prstGeom>
-          <a:noFill/>
-        </p:spPr>
-        <p:txBody>
-          <a:bodyPr wrap="square" rtlCol="0">
-            <a:spAutoFit/>
-          </a:bodyPr>
-          <a:lstStyle/>
-          <a:p>
-            <a:pPr algn="r"/>
-            <a:r>
-              <a:rPr lang="en-US" sz="800" dirty="0"/>
-              <a:t>LINE age</a:t>
-            </a:r>
-          </a:p>
-        </p:txBody>
-      </p:sp>
-      <p:sp>
-        <p:nvSpPr>
-          <p:cNvPr id="70" name="TextBox 69">
-            <a:extLst>
-              <a:ext uri="{FF2B5EF4-FFF2-40B4-BE49-F238E27FC236}">
-                <a16:creationId xmlns:a16="http://schemas.microsoft.com/office/drawing/2014/main" id="{86BFA92A-FA7D-05F0-044F-08FB460C8F7F}"/>
-              </a:ext>
-            </a:extLst>
-          </p:cNvPr>
-          <p:cNvSpPr txBox="1"/>
-          <p:nvPr/>
-        </p:nvSpPr>
-        <p:spPr>
-          <a:xfrm>
-            <a:off x="15818874" y="17237364"/>
-            <a:ext cx="1524000" cy="215444"/>
-          </a:xfrm>
-          <a:prstGeom prst="rect">
-            <a:avLst/>
-          </a:prstGeom>
-          <a:noFill/>
-        </p:spPr>
-        <p:txBody>
-          <a:bodyPr wrap="square" rtlCol="0">
-            <a:spAutoFit/>
-          </a:bodyPr>
-          <a:lstStyle/>
-          <a:p>
-            <a:pPr algn="r"/>
-            <a:r>
-              <a:rPr lang="en-US" sz="800" dirty="0"/>
-              <a:t>LINE age</a:t>
-            </a:r>
-          </a:p>
-        </p:txBody>
-      </p:sp>
-      <p:sp>
-        <p:nvSpPr>
-          <p:cNvPr id="71" name="TextBox 70">
-            <a:extLst>
-              <a:ext uri="{FF2B5EF4-FFF2-40B4-BE49-F238E27FC236}">
-                <a16:creationId xmlns:a16="http://schemas.microsoft.com/office/drawing/2014/main" id="{8F55A254-B588-FBCF-5712-C0E2822902EE}"/>
-              </a:ext>
-            </a:extLst>
-          </p:cNvPr>
-          <p:cNvSpPr txBox="1"/>
-          <p:nvPr/>
-        </p:nvSpPr>
-        <p:spPr>
-          <a:xfrm>
-            <a:off x="15818874" y="17470926"/>
-            <a:ext cx="1524000" cy="215444"/>
-          </a:xfrm>
-          <a:prstGeom prst="rect">
-            <a:avLst/>
-          </a:prstGeom>
-          <a:noFill/>
-        </p:spPr>
-        <p:txBody>
-          <a:bodyPr wrap="square" rtlCol="0">
-            <a:spAutoFit/>
-          </a:bodyPr>
-          <a:lstStyle/>
-          <a:p>
-            <a:pPr algn="r"/>
-            <a:r>
-              <a:rPr lang="en-US" sz="800" dirty="0"/>
-              <a:t>Others age</a:t>
-            </a:r>
-          </a:p>
-        </p:txBody>
-      </p:sp>
-      <p:sp>
-        <p:nvSpPr>
-          <p:cNvPr id="72" name="TextBox 71">
-            <a:extLst>
-              <a:ext uri="{FF2B5EF4-FFF2-40B4-BE49-F238E27FC236}">
-                <a16:creationId xmlns:a16="http://schemas.microsoft.com/office/drawing/2014/main" id="{D6F7BD20-87DC-829B-6DE6-CB0646E137A9}"/>
-              </a:ext>
-            </a:extLst>
-          </p:cNvPr>
-          <p:cNvSpPr txBox="1"/>
-          <p:nvPr/>
-        </p:nvSpPr>
-        <p:spPr>
-          <a:xfrm>
-            <a:off x="15818874" y="17706171"/>
-            <a:ext cx="1524000" cy="215444"/>
-          </a:xfrm>
-          <a:prstGeom prst="rect">
-            <a:avLst/>
-          </a:prstGeom>
-          <a:noFill/>
-        </p:spPr>
-        <p:txBody>
-          <a:bodyPr wrap="square" rtlCol="0">
-            <a:spAutoFit/>
-          </a:bodyPr>
-          <a:lstStyle/>
-          <a:p>
-            <a:pPr algn="r"/>
-            <a:r>
-              <a:rPr lang="en-US" sz="800" dirty="0"/>
-              <a:t>SINE age</a:t>
-            </a:r>
-          </a:p>
-        </p:txBody>
-      </p:sp>
-      <p:sp>
-        <p:nvSpPr>
-          <p:cNvPr id="73" name="TextBox 72">
-            <a:extLst>
-              <a:ext uri="{FF2B5EF4-FFF2-40B4-BE49-F238E27FC236}">
-                <a16:creationId xmlns:a16="http://schemas.microsoft.com/office/drawing/2014/main" id="{3A41FB5C-DF29-6CE6-CF1E-C2ED01BC8716}"/>
-              </a:ext>
-            </a:extLst>
-          </p:cNvPr>
-          <p:cNvSpPr txBox="1"/>
-          <p:nvPr/>
-        </p:nvSpPr>
-        <p:spPr>
-          <a:xfrm>
-            <a:off x="15818874" y="17937003"/>
-            <a:ext cx="1524000" cy="215444"/>
-          </a:xfrm>
-          <a:prstGeom prst="rect">
-            <a:avLst/>
-          </a:prstGeom>
-          <a:noFill/>
-        </p:spPr>
-        <p:txBody>
-          <a:bodyPr wrap="square" rtlCol="0">
-            <a:spAutoFit/>
-          </a:bodyPr>
-          <a:lstStyle/>
-          <a:p>
-            <a:pPr algn="r"/>
-            <a:r>
-              <a:rPr lang="en-US" sz="800" dirty="0"/>
-              <a:t>Unknown age x prop.</a:t>
-            </a:r>
-          </a:p>
-        </p:txBody>
-      </p:sp>
-      <p:sp>
-        <p:nvSpPr>
-          <p:cNvPr id="74" name="TextBox 73">
-            <a:extLst>
-              <a:ext uri="{FF2B5EF4-FFF2-40B4-BE49-F238E27FC236}">
-                <a16:creationId xmlns:a16="http://schemas.microsoft.com/office/drawing/2014/main" id="{00351ADD-B5BB-808D-BD5E-1A7B8246AE71}"/>
-              </a:ext>
-            </a:extLst>
-          </p:cNvPr>
-          <p:cNvSpPr txBox="1"/>
-          <p:nvPr/>
-        </p:nvSpPr>
-        <p:spPr>
-          <a:xfrm>
-            <a:off x="15818874" y="18170216"/>
-            <a:ext cx="1524000" cy="215444"/>
-          </a:xfrm>
-          <a:prstGeom prst="rect">
-            <a:avLst/>
-          </a:prstGeom>
-          <a:noFill/>
-        </p:spPr>
-        <p:txBody>
-          <a:bodyPr wrap="square" rtlCol="0">
-            <a:spAutoFit/>
-          </a:bodyPr>
-          <a:lstStyle/>
-          <a:p>
-            <a:pPr algn="r"/>
-            <a:r>
-              <a:rPr lang="en-US" sz="800" dirty="0"/>
-              <a:t>LINE proportion</a:t>
-            </a:r>
-          </a:p>
-        </p:txBody>
-      </p:sp>
-      <p:sp>
-        <p:nvSpPr>
-          <p:cNvPr id="75" name="TextBox 74">
-            <a:extLst>
-              <a:ext uri="{FF2B5EF4-FFF2-40B4-BE49-F238E27FC236}">
-                <a16:creationId xmlns:a16="http://schemas.microsoft.com/office/drawing/2014/main" id="{4EF86A72-1C7A-1653-7AF4-DB70AEABF595}"/>
-              </a:ext>
-            </a:extLst>
-          </p:cNvPr>
-          <p:cNvSpPr txBox="1"/>
-          <p:nvPr/>
-        </p:nvSpPr>
-        <p:spPr>
-          <a:xfrm>
-            <a:off x="15818874" y="18403429"/>
-            <a:ext cx="1524000" cy="215444"/>
-          </a:xfrm>
-          <a:prstGeom prst="rect">
-            <a:avLst/>
-          </a:prstGeom>
-          <a:noFill/>
-        </p:spPr>
-        <p:txBody>
-          <a:bodyPr wrap="square" rtlCol="0">
-            <a:spAutoFit/>
-          </a:bodyPr>
-          <a:lstStyle/>
-          <a:p>
-            <a:pPr algn="r"/>
-            <a:r>
-              <a:rPr lang="en-US" sz="800" dirty="0"/>
-              <a:t>Others proportion</a:t>
-            </a:r>
-          </a:p>
-        </p:txBody>
-      </p:sp>
-      <p:sp>
-        <p:nvSpPr>
-          <p:cNvPr id="76" name="TextBox 75">
-            <a:extLst>
-              <a:ext uri="{FF2B5EF4-FFF2-40B4-BE49-F238E27FC236}">
-                <a16:creationId xmlns:a16="http://schemas.microsoft.com/office/drawing/2014/main" id="{874F92EC-7018-0838-73B8-5B160D30DB6E}"/>
-              </a:ext>
-            </a:extLst>
-          </p:cNvPr>
-          <p:cNvSpPr txBox="1"/>
-          <p:nvPr/>
-        </p:nvSpPr>
-        <p:spPr>
-          <a:xfrm>
-            <a:off x="15818874" y="18636642"/>
-            <a:ext cx="1524000" cy="215444"/>
-          </a:xfrm>
-          <a:prstGeom prst="rect">
-            <a:avLst/>
-          </a:prstGeom>
-          <a:noFill/>
-        </p:spPr>
-        <p:txBody>
-          <a:bodyPr wrap="square" rtlCol="0">
-            <a:spAutoFit/>
-          </a:bodyPr>
-          <a:lstStyle/>
-          <a:p>
-            <a:pPr algn="r"/>
-            <a:r>
-              <a:rPr lang="en-US" sz="800" dirty="0"/>
-              <a:t>Unknown proportion</a:t>
-            </a:r>
-          </a:p>
-        </p:txBody>
-      </p:sp>
-      <p:sp>
-        <p:nvSpPr>
-          <p:cNvPr id="77" name="TextBox 76">
-            <a:extLst>
-              <a:ext uri="{FF2B5EF4-FFF2-40B4-BE49-F238E27FC236}">
-                <a16:creationId xmlns:a16="http://schemas.microsoft.com/office/drawing/2014/main" id="{42A8FE68-27BA-7288-4CC7-9F1BA9B3F771}"/>
-              </a:ext>
-            </a:extLst>
-          </p:cNvPr>
-          <p:cNvSpPr txBox="1"/>
-          <p:nvPr/>
-        </p:nvSpPr>
-        <p:spPr>
-          <a:xfrm>
-            <a:off x="15818874" y="16891465"/>
-            <a:ext cx="1524000" cy="215444"/>
-          </a:xfrm>
-          <a:prstGeom prst="rect">
-            <a:avLst/>
-          </a:prstGeom>
-          <a:noFill/>
-        </p:spPr>
-        <p:txBody>
-          <a:bodyPr wrap="square" rtlCol="0">
-            <a:spAutoFit/>
-          </a:bodyPr>
-          <a:lstStyle/>
-          <a:p>
-            <a:pPr algn="r"/>
-            <a:r>
-              <a:rPr lang="en-US" sz="800" dirty="0"/>
-              <a:t>DNA age x prop.</a:t>
-            </a:r>
-          </a:p>
-        </p:txBody>
-      </p:sp>
-      <p:sp>
-        <p:nvSpPr>
-          <p:cNvPr id="78" name="TextBox 77">
-            <a:extLst>
-              <a:ext uri="{FF2B5EF4-FFF2-40B4-BE49-F238E27FC236}">
-                <a16:creationId xmlns:a16="http://schemas.microsoft.com/office/drawing/2014/main" id="{39325659-4890-5C11-A4AF-8CACD7EDDFA7}"/>
-              </a:ext>
-            </a:extLst>
-          </p:cNvPr>
-          <p:cNvSpPr txBox="1"/>
-          <p:nvPr/>
-        </p:nvSpPr>
-        <p:spPr>
-          <a:xfrm>
-            <a:off x="15818683" y="17124374"/>
-            <a:ext cx="1524000" cy="215444"/>
-          </a:xfrm>
-          <a:prstGeom prst="rect">
-            <a:avLst/>
-          </a:prstGeom>
-          <a:noFill/>
-        </p:spPr>
-        <p:txBody>
-          <a:bodyPr wrap="square" rtlCol="0">
-            <a:spAutoFit/>
-          </a:bodyPr>
-          <a:lstStyle/>
-          <a:p>
-            <a:pPr algn="r"/>
-            <a:r>
-              <a:rPr lang="en-US" sz="800" dirty="0"/>
-              <a:t>LINE age x prop.</a:t>
-            </a:r>
-          </a:p>
-        </p:txBody>
-      </p:sp>
-      <p:sp>
-        <p:nvSpPr>
-          <p:cNvPr id="79" name="TextBox 78">
-            <a:extLst>
-              <a:ext uri="{FF2B5EF4-FFF2-40B4-BE49-F238E27FC236}">
-                <a16:creationId xmlns:a16="http://schemas.microsoft.com/office/drawing/2014/main" id="{07CA8625-0741-BF34-96CA-38949C84C5C8}"/>
-              </a:ext>
-            </a:extLst>
-          </p:cNvPr>
-          <p:cNvSpPr txBox="1"/>
-          <p:nvPr/>
-        </p:nvSpPr>
-        <p:spPr>
-          <a:xfrm>
-            <a:off x="15818264" y="17354812"/>
-            <a:ext cx="1524000" cy="215444"/>
-          </a:xfrm>
-          <a:prstGeom prst="rect">
-            <a:avLst/>
-          </a:prstGeom>
-          <a:noFill/>
-        </p:spPr>
-        <p:txBody>
-          <a:bodyPr wrap="square" rtlCol="0">
-            <a:spAutoFit/>
-          </a:bodyPr>
-          <a:lstStyle/>
-          <a:p>
-            <a:pPr algn="r"/>
-            <a:r>
-              <a:rPr lang="en-US" sz="800" dirty="0"/>
-              <a:t>LTR age x prop.</a:t>
-            </a:r>
-          </a:p>
-        </p:txBody>
-      </p:sp>
-      <p:sp>
-        <p:nvSpPr>
-          <p:cNvPr id="80" name="TextBox 79">
-            <a:extLst>
-              <a:ext uri="{FF2B5EF4-FFF2-40B4-BE49-F238E27FC236}">
-                <a16:creationId xmlns:a16="http://schemas.microsoft.com/office/drawing/2014/main" id="{0081DD2E-9FB7-BCCA-A674-CE371FD63317}"/>
-              </a:ext>
-            </a:extLst>
-          </p:cNvPr>
-          <p:cNvSpPr txBox="1"/>
-          <p:nvPr/>
-        </p:nvSpPr>
-        <p:spPr>
-          <a:xfrm>
-            <a:off x="15818683" y="17588329"/>
-            <a:ext cx="1524000" cy="215444"/>
-          </a:xfrm>
-          <a:prstGeom prst="rect">
-            <a:avLst/>
-          </a:prstGeom>
-          <a:noFill/>
-        </p:spPr>
-        <p:txBody>
-          <a:bodyPr wrap="square" rtlCol="0">
-            <a:spAutoFit/>
-          </a:bodyPr>
-          <a:lstStyle/>
-          <a:p>
-            <a:pPr algn="r"/>
-            <a:r>
-              <a:rPr lang="en-US" sz="800" dirty="0"/>
-              <a:t>Others age x prop.</a:t>
-            </a:r>
-          </a:p>
-        </p:txBody>
-      </p:sp>
-      <p:sp>
-        <p:nvSpPr>
-          <p:cNvPr id="81" name="TextBox 80">
-            <a:extLst>
-              <a:ext uri="{FF2B5EF4-FFF2-40B4-BE49-F238E27FC236}">
-                <a16:creationId xmlns:a16="http://schemas.microsoft.com/office/drawing/2014/main" id="{8E5EB311-BF47-869F-2CFC-9ED53ABD5061}"/>
-              </a:ext>
-            </a:extLst>
-          </p:cNvPr>
-          <p:cNvSpPr txBox="1"/>
-          <p:nvPr/>
-        </p:nvSpPr>
-        <p:spPr>
-          <a:xfrm>
-            <a:off x="15818264" y="17821635"/>
-            <a:ext cx="1524000" cy="215444"/>
-          </a:xfrm>
-          <a:prstGeom prst="rect">
-            <a:avLst/>
-          </a:prstGeom>
-          <a:noFill/>
-        </p:spPr>
-        <p:txBody>
-          <a:bodyPr wrap="square" rtlCol="0">
-            <a:spAutoFit/>
-          </a:bodyPr>
-          <a:lstStyle/>
-          <a:p>
-            <a:pPr algn="r"/>
-            <a:r>
-              <a:rPr lang="en-US" sz="800" dirty="0"/>
-              <a:t>Unknown age</a:t>
-            </a:r>
-          </a:p>
-        </p:txBody>
-      </p:sp>
-      <p:sp>
-        <p:nvSpPr>
-          <p:cNvPr id="82" name="TextBox 81">
-            <a:extLst>
-              <a:ext uri="{FF2B5EF4-FFF2-40B4-BE49-F238E27FC236}">
-                <a16:creationId xmlns:a16="http://schemas.microsoft.com/office/drawing/2014/main" id="{7223B53B-F300-0201-737B-5C47A5908E0C}"/>
-              </a:ext>
-            </a:extLst>
-          </p:cNvPr>
-          <p:cNvSpPr txBox="1"/>
-          <p:nvPr/>
-        </p:nvSpPr>
-        <p:spPr>
-          <a:xfrm>
-            <a:off x="15819730" y="18052374"/>
-            <a:ext cx="1524000" cy="215444"/>
-          </a:xfrm>
-          <a:prstGeom prst="rect">
-            <a:avLst/>
-          </a:prstGeom>
-          <a:noFill/>
-        </p:spPr>
-        <p:txBody>
-          <a:bodyPr wrap="square" rtlCol="0">
-            <a:spAutoFit/>
-          </a:bodyPr>
-          <a:lstStyle/>
-          <a:p>
-            <a:pPr algn="r"/>
-            <a:r>
-              <a:rPr lang="en-US" sz="800" dirty="0"/>
-              <a:t>DNA proportion</a:t>
-            </a:r>
-          </a:p>
-        </p:txBody>
-      </p:sp>
-      <p:sp>
-        <p:nvSpPr>
-          <p:cNvPr id="83" name="TextBox 82">
-            <a:extLst>
-              <a:ext uri="{FF2B5EF4-FFF2-40B4-BE49-F238E27FC236}">
-                <a16:creationId xmlns:a16="http://schemas.microsoft.com/office/drawing/2014/main" id="{1779232D-30BD-7528-5E44-936B0CC1E9CA}"/>
-              </a:ext>
-            </a:extLst>
-          </p:cNvPr>
-          <p:cNvSpPr txBox="1"/>
-          <p:nvPr/>
-        </p:nvSpPr>
-        <p:spPr>
-          <a:xfrm>
-            <a:off x="15818264" y="18285494"/>
-            <a:ext cx="1524000" cy="215444"/>
-          </a:xfrm>
-          <a:prstGeom prst="rect">
-            <a:avLst/>
-          </a:prstGeom>
-          <a:noFill/>
-        </p:spPr>
-        <p:txBody>
-          <a:bodyPr wrap="square" rtlCol="0">
-            <a:spAutoFit/>
-          </a:bodyPr>
-          <a:lstStyle/>
-          <a:p>
-            <a:pPr algn="r"/>
-            <a:r>
-              <a:rPr lang="en-US" sz="800" dirty="0"/>
-              <a:t>LTR proportion</a:t>
-            </a:r>
-          </a:p>
-        </p:txBody>
-      </p:sp>
-      <p:sp>
-        <p:nvSpPr>
-          <p:cNvPr id="84" name="TextBox 83">
-            <a:extLst>
-              <a:ext uri="{FF2B5EF4-FFF2-40B4-BE49-F238E27FC236}">
-                <a16:creationId xmlns:a16="http://schemas.microsoft.com/office/drawing/2014/main" id="{C01643B8-DE22-DF1E-3724-AE0CF28EF8F2}"/>
-              </a:ext>
-            </a:extLst>
-          </p:cNvPr>
-          <p:cNvSpPr txBox="1"/>
-          <p:nvPr/>
-        </p:nvSpPr>
-        <p:spPr>
-          <a:xfrm>
-            <a:off x="15818264" y="18517710"/>
-            <a:ext cx="1524000" cy="215444"/>
-          </a:xfrm>
-          <a:prstGeom prst="rect">
-            <a:avLst/>
-          </a:prstGeom>
-          <a:noFill/>
-        </p:spPr>
-        <p:txBody>
-          <a:bodyPr wrap="square" rtlCol="0">
-            <a:spAutoFit/>
-          </a:bodyPr>
-          <a:lstStyle/>
-          <a:p>
-            <a:pPr algn="r"/>
-            <a:r>
-              <a:rPr lang="en-US" sz="800" dirty="0"/>
-              <a:t>SINE proportion</a:t>
+              <a:t>1</a:t>
             </a:r>
           </a:p>
         </p:txBody>
@@ -14936,7 +13928,7 @@
         </p:nvSpPr>
         <p:spPr>
           <a:xfrm>
-            <a:off x="15624998" y="13911093"/>
+            <a:off x="15767873" y="13911093"/>
             <a:ext cx="1717685" cy="261610"/>
           </a:xfrm>
           <a:prstGeom prst="rect">
@@ -14972,7 +13964,7 @@
         </p:nvSpPr>
         <p:spPr>
           <a:xfrm>
-            <a:off x="15623735" y="14287247"/>
+            <a:off x="15766610" y="14287247"/>
             <a:ext cx="1717685" cy="261610"/>
           </a:xfrm>
           <a:prstGeom prst="rect">
@@ -15008,7 +14000,7 @@
         </p:nvSpPr>
         <p:spPr>
           <a:xfrm>
-            <a:off x="15622617" y="14659451"/>
+            <a:off x="15765492" y="14659451"/>
             <a:ext cx="1717685" cy="261610"/>
           </a:xfrm>
           <a:prstGeom prst="rect">
@@ -15044,7 +14036,7 @@
         </p:nvSpPr>
         <p:spPr>
           <a:xfrm>
-            <a:off x="15622016" y="15032077"/>
+            <a:off x="15764891" y="15032077"/>
             <a:ext cx="1717685" cy="261610"/>
           </a:xfrm>
           <a:prstGeom prst="rect">
@@ -15080,7 +14072,7 @@
         </p:nvSpPr>
         <p:spPr>
           <a:xfrm>
-            <a:off x="15623735" y="15407629"/>
+            <a:off x="15766610" y="15407629"/>
             <a:ext cx="1717685" cy="261610"/>
           </a:xfrm>
           <a:prstGeom prst="rect">
@@ -15296,7 +14288,7 @@
         </p:nvSpPr>
         <p:spPr>
           <a:xfrm>
-            <a:off x="15945263" y="13349486"/>
+            <a:off x="16088138" y="13349486"/>
             <a:ext cx="3400931" cy="307777"/>
           </a:xfrm>
           <a:prstGeom prst="rect">
@@ -15332,7 +14324,7 @@
         </p:nvSpPr>
         <p:spPr>
           <a:xfrm>
-            <a:off x="19441617" y="13349095"/>
+            <a:off x="19584492" y="13349095"/>
             <a:ext cx="1849054" cy="307777"/>
           </a:xfrm>
           <a:prstGeom prst="rect">
@@ -15440,7 +14432,7 @@
         </p:nvSpPr>
         <p:spPr>
           <a:xfrm>
-            <a:off x="15945263" y="16377040"/>
+            <a:off x="16088138" y="16377040"/>
             <a:ext cx="3400931" cy="307777"/>
           </a:xfrm>
           <a:prstGeom prst="rect">
@@ -15465,7 +14457,7 @@
             </a:r>
             <a:r>
               <a:rPr lang="en-US" dirty="0"/>
-              <a:t> (2 models)</a:t>
+              <a:t> (729 models)</a:t>
             </a:r>
           </a:p>
         </p:txBody>
@@ -15484,7 +14476,7 @@
         </p:nvSpPr>
         <p:spPr>
           <a:xfrm>
-            <a:off x="19441617" y="16376649"/>
+            <a:off x="19584492" y="16376649"/>
             <a:ext cx="1849054" cy="307777"/>
           </a:xfrm>
           <a:prstGeom prst="rect">
@@ -15520,7 +14512,7 @@
         </p:nvSpPr>
         <p:spPr>
           <a:xfrm>
-            <a:off x="17803014" y="19293583"/>
+            <a:off x="17945889" y="19293583"/>
             <a:ext cx="3127374" cy="307777"/>
           </a:xfrm>
           <a:prstGeom prst="rect">
@@ -15611,7 +14603,7 @@
         </p:blipFill>
         <p:spPr>
           <a:xfrm>
-            <a:off x="21133571" y="14477760"/>
+            <a:off x="21276446" y="14477760"/>
             <a:ext cx="1811622" cy="850123"/>
           </a:xfrm>
           <a:prstGeom prst="rect">
@@ -15633,7 +14625,7 @@
         </p:nvGrpSpPr>
         <p:grpSpPr>
           <a:xfrm>
-            <a:off x="21456564" y="15554947"/>
+            <a:off x="21599439" y="15554947"/>
             <a:ext cx="3436207" cy="3316189"/>
             <a:chOff x="22197688" y="19295876"/>
             <a:chExt cx="3436207" cy="3316189"/>
@@ -16019,7 +15011,7 @@
         </p:nvSpPr>
         <p:spPr>
           <a:xfrm>
-            <a:off x="21439680" y="13827276"/>
+            <a:off x="21582555" y="13827276"/>
             <a:ext cx="2039618" cy="584775"/>
           </a:xfrm>
           <a:prstGeom prst="rect">
@@ -16042,6 +15034,474 @@
             <a:r>
               <a:rPr lang="en-US" sz="1600" dirty="0"/>
               <a:t>metric</a:t>
+            </a:r>
+          </a:p>
+        </p:txBody>
+      </p:sp>
+      <p:sp>
+        <p:nvSpPr>
+          <p:cNvPr id="52" name="TextBox 51">
+            <a:extLst>
+              <a:ext uri="{FF2B5EF4-FFF2-40B4-BE49-F238E27FC236}">
+                <a16:creationId xmlns:a16="http://schemas.microsoft.com/office/drawing/2014/main" id="{EACB2203-CECE-98A9-9454-68C6E6F2FD38}"/>
+              </a:ext>
+            </a:extLst>
+          </p:cNvPr>
+          <p:cNvSpPr txBox="1"/>
+          <p:nvPr/>
+        </p:nvSpPr>
+        <p:spPr>
+          <a:xfrm>
+            <a:off x="15767589" y="16841465"/>
+            <a:ext cx="1717685" cy="261610"/>
+          </a:xfrm>
+          <a:prstGeom prst="rect">
+            <a:avLst/>
+          </a:prstGeom>
+          <a:noFill/>
+        </p:spPr>
+        <p:txBody>
+          <a:bodyPr wrap="square" rtlCol="0">
+            <a:spAutoFit/>
+          </a:bodyPr>
+          <a:lstStyle/>
+          <a:p>
+            <a:pPr algn="r"/>
+            <a:r>
+              <a:rPr lang="en-US" sz="1100" dirty="0"/>
+              <a:t>LINE age</a:t>
+            </a:r>
+          </a:p>
+        </p:txBody>
+      </p:sp>
+      <p:sp>
+        <p:nvSpPr>
+          <p:cNvPr id="55" name="TextBox 54">
+            <a:extLst>
+              <a:ext uri="{FF2B5EF4-FFF2-40B4-BE49-F238E27FC236}">
+                <a16:creationId xmlns:a16="http://schemas.microsoft.com/office/drawing/2014/main" id="{9AD832C8-B45A-7A19-DFB6-216BD5ADAABB}"/>
+              </a:ext>
+            </a:extLst>
+          </p:cNvPr>
+          <p:cNvSpPr txBox="1"/>
+          <p:nvPr/>
+        </p:nvSpPr>
+        <p:spPr>
+          <a:xfrm>
+            <a:off x="15767272" y="17084292"/>
+            <a:ext cx="1717685" cy="261610"/>
+          </a:xfrm>
+          <a:prstGeom prst="rect">
+            <a:avLst/>
+          </a:prstGeom>
+          <a:noFill/>
+        </p:spPr>
+        <p:txBody>
+          <a:bodyPr wrap="square" rtlCol="0">
+            <a:spAutoFit/>
+          </a:bodyPr>
+          <a:lstStyle/>
+          <a:p>
+            <a:pPr algn="r"/>
+            <a:r>
+              <a:rPr lang="en-US" sz="1100" dirty="0"/>
+              <a:t>LTR age</a:t>
+            </a:r>
+          </a:p>
+        </p:txBody>
+      </p:sp>
+      <p:sp>
+        <p:nvSpPr>
+          <p:cNvPr id="56" name="TextBox 55">
+            <a:extLst>
+              <a:ext uri="{FF2B5EF4-FFF2-40B4-BE49-F238E27FC236}">
+                <a16:creationId xmlns:a16="http://schemas.microsoft.com/office/drawing/2014/main" id="{E7284523-594E-75D4-CBD9-EB8DD9A8CF49}"/>
+              </a:ext>
+            </a:extLst>
+          </p:cNvPr>
+          <p:cNvSpPr txBox="1"/>
+          <p:nvPr/>
+        </p:nvSpPr>
+        <p:spPr>
+          <a:xfrm>
+            <a:off x="15767270" y="17324800"/>
+            <a:ext cx="1717685" cy="261610"/>
+          </a:xfrm>
+          <a:prstGeom prst="rect">
+            <a:avLst/>
+          </a:prstGeom>
+          <a:noFill/>
+        </p:spPr>
+        <p:txBody>
+          <a:bodyPr wrap="square" rtlCol="0">
+            <a:spAutoFit/>
+          </a:bodyPr>
+          <a:lstStyle/>
+          <a:p>
+            <a:pPr algn="r"/>
+            <a:r>
+              <a:rPr lang="en-US" sz="1100" dirty="0"/>
+              <a:t>SINE age</a:t>
+            </a:r>
+          </a:p>
+        </p:txBody>
+      </p:sp>
+      <p:sp>
+        <p:nvSpPr>
+          <p:cNvPr id="57" name="TextBox 56">
+            <a:extLst>
+              <a:ext uri="{FF2B5EF4-FFF2-40B4-BE49-F238E27FC236}">
+                <a16:creationId xmlns:a16="http://schemas.microsoft.com/office/drawing/2014/main" id="{9AF58A6A-48AD-0953-A58A-923FD8B1A97C}"/>
+              </a:ext>
+            </a:extLst>
+          </p:cNvPr>
+          <p:cNvSpPr txBox="1"/>
+          <p:nvPr/>
+        </p:nvSpPr>
+        <p:spPr>
+          <a:xfrm>
+            <a:off x="15767269" y="17565307"/>
+            <a:ext cx="1717685" cy="261610"/>
+          </a:xfrm>
+          <a:prstGeom prst="rect">
+            <a:avLst/>
+          </a:prstGeom>
+          <a:noFill/>
+        </p:spPr>
+        <p:txBody>
+          <a:bodyPr wrap="square" rtlCol="0">
+            <a:spAutoFit/>
+          </a:bodyPr>
+          <a:lstStyle/>
+          <a:p>
+            <a:pPr algn="r"/>
+            <a:r>
+              <a:rPr lang="en-US" sz="1100" dirty="0"/>
+              <a:t>Unknown age</a:t>
+            </a:r>
+          </a:p>
+        </p:txBody>
+      </p:sp>
+      <p:sp>
+        <p:nvSpPr>
+          <p:cNvPr id="58" name="TextBox 57">
+            <a:extLst>
+              <a:ext uri="{FF2B5EF4-FFF2-40B4-BE49-F238E27FC236}">
+                <a16:creationId xmlns:a16="http://schemas.microsoft.com/office/drawing/2014/main" id="{B2424BB6-AA91-5C95-1539-0E3024AF6337}"/>
+              </a:ext>
+            </a:extLst>
+          </p:cNvPr>
+          <p:cNvSpPr txBox="1"/>
+          <p:nvPr/>
+        </p:nvSpPr>
+        <p:spPr>
+          <a:xfrm>
+            <a:off x="15767268" y="17805815"/>
+            <a:ext cx="1717685" cy="261610"/>
+          </a:xfrm>
+          <a:prstGeom prst="rect">
+            <a:avLst/>
+          </a:prstGeom>
+          <a:noFill/>
+        </p:spPr>
+        <p:txBody>
+          <a:bodyPr wrap="square" rtlCol="0">
+            <a:spAutoFit/>
+          </a:bodyPr>
+          <a:lstStyle/>
+          <a:p>
+            <a:pPr algn="r"/>
+            <a:r>
+              <a:rPr lang="en-US" sz="1100" dirty="0"/>
+              <a:t>LINE proportion</a:t>
+            </a:r>
+          </a:p>
+        </p:txBody>
+      </p:sp>
+      <p:sp>
+        <p:nvSpPr>
+          <p:cNvPr id="59" name="TextBox 58">
+            <a:extLst>
+              <a:ext uri="{FF2B5EF4-FFF2-40B4-BE49-F238E27FC236}">
+                <a16:creationId xmlns:a16="http://schemas.microsoft.com/office/drawing/2014/main" id="{ED207BA9-6031-2D2A-2E78-C092EE83FE0D}"/>
+              </a:ext>
+            </a:extLst>
+          </p:cNvPr>
+          <p:cNvSpPr txBox="1"/>
+          <p:nvPr/>
+        </p:nvSpPr>
+        <p:spPr>
+          <a:xfrm>
+            <a:off x="15767266" y="18046323"/>
+            <a:ext cx="1717685" cy="261610"/>
+          </a:xfrm>
+          <a:prstGeom prst="rect">
+            <a:avLst/>
+          </a:prstGeom>
+          <a:noFill/>
+        </p:spPr>
+        <p:txBody>
+          <a:bodyPr wrap="square" rtlCol="0">
+            <a:spAutoFit/>
+          </a:bodyPr>
+          <a:lstStyle/>
+          <a:p>
+            <a:pPr algn="r"/>
+            <a:r>
+              <a:rPr lang="en-US" sz="1100" dirty="0"/>
+              <a:t>LTR proportion</a:t>
+            </a:r>
+          </a:p>
+        </p:txBody>
+      </p:sp>
+      <p:sp>
+        <p:nvSpPr>
+          <p:cNvPr id="85" name="TextBox 84">
+            <a:extLst>
+              <a:ext uri="{FF2B5EF4-FFF2-40B4-BE49-F238E27FC236}">
+                <a16:creationId xmlns:a16="http://schemas.microsoft.com/office/drawing/2014/main" id="{83E4B6B6-0BE3-EEAC-B7F8-79E4D1F043AE}"/>
+              </a:ext>
+            </a:extLst>
+          </p:cNvPr>
+          <p:cNvSpPr txBox="1"/>
+          <p:nvPr/>
+        </p:nvSpPr>
+        <p:spPr>
+          <a:xfrm>
+            <a:off x="15767264" y="18286832"/>
+            <a:ext cx="1717685" cy="261610"/>
+          </a:xfrm>
+          <a:prstGeom prst="rect">
+            <a:avLst/>
+          </a:prstGeom>
+          <a:noFill/>
+        </p:spPr>
+        <p:txBody>
+          <a:bodyPr wrap="square" rtlCol="0">
+            <a:spAutoFit/>
+          </a:bodyPr>
+          <a:lstStyle/>
+          <a:p>
+            <a:pPr algn="r"/>
+            <a:r>
+              <a:rPr lang="en-US" sz="1100" dirty="0"/>
+              <a:t>Others proportion</a:t>
+            </a:r>
+          </a:p>
+        </p:txBody>
+      </p:sp>
+      <p:sp>
+        <p:nvSpPr>
+          <p:cNvPr id="95" name="TextBox 94">
+            <a:extLst>
+              <a:ext uri="{FF2B5EF4-FFF2-40B4-BE49-F238E27FC236}">
+                <a16:creationId xmlns:a16="http://schemas.microsoft.com/office/drawing/2014/main" id="{3E2CC2D5-DD53-467D-F9DD-85ACC78EE533}"/>
+              </a:ext>
+            </a:extLst>
+          </p:cNvPr>
+          <p:cNvSpPr txBox="1"/>
+          <p:nvPr/>
+        </p:nvSpPr>
+        <p:spPr>
+          <a:xfrm>
+            <a:off x="15767262" y="18527341"/>
+            <a:ext cx="1717685" cy="261610"/>
+          </a:xfrm>
+          <a:prstGeom prst="rect">
+            <a:avLst/>
+          </a:prstGeom>
+          <a:noFill/>
+        </p:spPr>
+        <p:txBody>
+          <a:bodyPr wrap="square" rtlCol="0">
+            <a:spAutoFit/>
+          </a:bodyPr>
+          <a:lstStyle/>
+          <a:p>
+            <a:pPr algn="r"/>
+            <a:r>
+              <a:rPr lang="en-US" sz="1100" dirty="0"/>
+              <a:t>Unknown proportion</a:t>
+            </a:r>
+          </a:p>
+        </p:txBody>
+      </p:sp>
+      <p:sp>
+        <p:nvSpPr>
+          <p:cNvPr id="130" name="TextBox 129">
+            <a:extLst>
+              <a:ext uri="{FF2B5EF4-FFF2-40B4-BE49-F238E27FC236}">
+                <a16:creationId xmlns:a16="http://schemas.microsoft.com/office/drawing/2014/main" id="{5BA5DF6B-146F-5548-4FDC-163284C3CA2F}"/>
+              </a:ext>
+            </a:extLst>
+          </p:cNvPr>
+          <p:cNvSpPr txBox="1"/>
+          <p:nvPr/>
+        </p:nvSpPr>
+        <p:spPr>
+          <a:xfrm>
+            <a:off x="19555674" y="19006092"/>
+            <a:ext cx="339726" cy="261610"/>
+          </a:xfrm>
+          <a:prstGeom prst="rect">
+            <a:avLst/>
+          </a:prstGeom>
+          <a:noFill/>
+        </p:spPr>
+        <p:txBody>
+          <a:bodyPr wrap="square" rtlCol="0">
+            <a:spAutoFit/>
+          </a:bodyPr>
+          <a:lstStyle/>
+          <a:p>
+            <a:pPr algn="ctr"/>
+            <a:r>
+              <a:rPr lang="en-US" sz="1100" dirty="0"/>
+              <a:t>-1</a:t>
+            </a:r>
+          </a:p>
+        </p:txBody>
+      </p:sp>
+      <p:sp>
+        <p:nvSpPr>
+          <p:cNvPr id="131" name="TextBox 130">
+            <a:extLst>
+              <a:ext uri="{FF2B5EF4-FFF2-40B4-BE49-F238E27FC236}">
+                <a16:creationId xmlns:a16="http://schemas.microsoft.com/office/drawing/2014/main" id="{03875274-BFBB-95DB-55C5-13F343F78556}"/>
+              </a:ext>
+            </a:extLst>
+          </p:cNvPr>
+          <p:cNvSpPr txBox="1"/>
+          <p:nvPr/>
+        </p:nvSpPr>
+        <p:spPr>
+          <a:xfrm>
+            <a:off x="19894805" y="19002739"/>
+            <a:ext cx="461156" cy="261610"/>
+          </a:xfrm>
+          <a:prstGeom prst="rect">
+            <a:avLst/>
+          </a:prstGeom>
+          <a:noFill/>
+        </p:spPr>
+        <p:txBody>
+          <a:bodyPr wrap="square" rtlCol="0">
+            <a:spAutoFit/>
+          </a:bodyPr>
+          <a:lstStyle/>
+          <a:p>
+            <a:pPr algn="ctr"/>
+            <a:r>
+              <a:rPr lang="en-US" sz="1100" dirty="0"/>
+              <a:t>-0.5</a:t>
+            </a:r>
+          </a:p>
+        </p:txBody>
+      </p:sp>
+      <p:sp>
+        <p:nvSpPr>
+          <p:cNvPr id="132" name="TextBox 131">
+            <a:extLst>
+              <a:ext uri="{FF2B5EF4-FFF2-40B4-BE49-F238E27FC236}">
+                <a16:creationId xmlns:a16="http://schemas.microsoft.com/office/drawing/2014/main" id="{B8962860-9071-E035-7108-A5C487337509}"/>
+              </a:ext>
+            </a:extLst>
+          </p:cNvPr>
+          <p:cNvSpPr txBox="1"/>
+          <p:nvPr/>
+        </p:nvSpPr>
+        <p:spPr>
+          <a:xfrm>
+            <a:off x="20352393" y="19002730"/>
+            <a:ext cx="339726" cy="261610"/>
+          </a:xfrm>
+          <a:prstGeom prst="rect">
+            <a:avLst/>
+          </a:prstGeom>
+          <a:noFill/>
+        </p:spPr>
+        <p:txBody>
+          <a:bodyPr wrap="square" rtlCol="0">
+            <a:spAutoFit/>
+          </a:bodyPr>
+          <a:lstStyle/>
+          <a:p>
+            <a:pPr algn="ctr"/>
+            <a:r>
+              <a:rPr lang="en-US" sz="1100" dirty="0"/>
+              <a:t>0</a:t>
+            </a:r>
+          </a:p>
+        </p:txBody>
+      </p:sp>
+      <p:sp>
+        <p:nvSpPr>
+          <p:cNvPr id="133" name="TextBox 132">
+            <a:extLst>
+              <a:ext uri="{FF2B5EF4-FFF2-40B4-BE49-F238E27FC236}">
+                <a16:creationId xmlns:a16="http://schemas.microsoft.com/office/drawing/2014/main" id="{2C727A33-969C-ECD1-2D29-0700EA484B6D}"/>
+              </a:ext>
+            </a:extLst>
+          </p:cNvPr>
+          <p:cNvSpPr txBox="1"/>
+          <p:nvPr/>
+        </p:nvSpPr>
+        <p:spPr>
+          <a:xfrm>
+            <a:off x="20669099" y="19002729"/>
+            <a:ext cx="502448" cy="261610"/>
+          </a:xfrm>
+          <a:prstGeom prst="rect">
+            <a:avLst/>
+          </a:prstGeom>
+          <a:noFill/>
+        </p:spPr>
+        <p:txBody>
+          <a:bodyPr wrap="square" rtlCol="0">
+            <a:spAutoFit/>
+          </a:bodyPr>
+          <a:lstStyle/>
+          <a:p>
+            <a:pPr algn="ctr"/>
+            <a:r>
+              <a:rPr lang="en-US" sz="1100" dirty="0"/>
+              <a:t>0.5</a:t>
+            </a:r>
+          </a:p>
+        </p:txBody>
+      </p:sp>
+      <p:sp>
+        <p:nvSpPr>
+          <p:cNvPr id="134" name="TextBox 133">
+            <a:extLst>
+              <a:ext uri="{FF2B5EF4-FFF2-40B4-BE49-F238E27FC236}">
+                <a16:creationId xmlns:a16="http://schemas.microsoft.com/office/drawing/2014/main" id="{FB7DD4AF-8936-04A4-0884-CCBF6AB80F4C}"/>
+              </a:ext>
+            </a:extLst>
+          </p:cNvPr>
+          <p:cNvSpPr txBox="1"/>
+          <p:nvPr/>
+        </p:nvSpPr>
+        <p:spPr>
+          <a:xfrm>
+            <a:off x="21147732" y="19002728"/>
+            <a:ext cx="339726" cy="261610"/>
+          </a:xfrm>
+          <a:prstGeom prst="rect">
+            <a:avLst/>
+          </a:prstGeom>
+          <a:noFill/>
+        </p:spPr>
+        <p:txBody>
+          <a:bodyPr wrap="square" rtlCol="0">
+            <a:spAutoFit/>
+          </a:bodyPr>
+          <a:lstStyle/>
+          <a:p>
+            <a:pPr algn="ctr"/>
+            <a:r>
+              <a:rPr lang="en-US" sz="1100" dirty="0"/>
+              <a:t>1</a:t>
             </a:r>
           </a:p>
         </p:txBody>

</xml_diff>